<commit_message>
Investor deck: final layout fixes, placeholder live URLs
Co-Authored-By: Claude Fable 5 <noreply@anthropic.com>
Claude-Session: https://claude.ai/code/session_019A8YQc7WWoitbc7BECpajF
</commit_message>
<xml_diff>
--- a/docs/pitch/Sentinel-Pitch.pptx
+++ b/docs/pitch/Sentinel-Pitch.pptx
@@ -4582,7 +4582,7 @@
                 </a:solidFill>
                 <a:latin typeface="Consolas"/>
               </a:rPr>
-              <a:t>http://localhost:3000</a:t>
+              <a:t>live demo: coming soon (Vercel)</a:t>
             </a:r>
           </a:p>
         </p:txBody>
@@ -10298,7 +10298,7 @@
                 </a:solidFill>
                 <a:latin typeface="Consolas"/>
               </a:rPr>
-              <a:t>web  http://localhost:3000</a:t>
+              <a:t>web  live demo: coming soon (Vercel)</a:t>
             </a:r>
           </a:p>
           <a:p>
@@ -10310,7 +10310,7 @@
                 </a:solidFill>
                 <a:latin typeface="Consolas"/>
               </a:rPr>
-              <a:t>api  http://localhost:8000</a:t>
+              <a:t>api  API: coming soon (Railway)</a:t>
             </a:r>
           </a:p>
           <a:p>
@@ -12978,7 +12978,7 @@
                 </a:solidFill>
                 <a:latin typeface="Segoe UI"/>
               </a:rPr>
-              <a:t> payment errors climb, latency climbs, DB connections climb. Dashboards light up. Every tool says *something is wrong*; none says *what changed and why*.</a:t>
+              <a:t> payment errors climb, latency climbs, DB connections climb. Dashboards light up. Every tool says “something is wrong”; none says what changed, and why.</a:t>
             </a:r>
           </a:p>
           <a:p>
@@ -13337,7 +13337,7 @@
                 </a:solidFill>
                 <a:latin typeface="Segoe UI"/>
               </a:rPr>
-              <a:t> http://localhost:3000  (admin@sentinel.local / admin12345)</a:t>
+              <a:t> live demo: coming soon (Vercel)  (admin@sentinel.local / admin12345)</a:t>
             </a:r>
           </a:p>
           <a:p>

</xml_diff>

<commit_message>
Live deployment: Vercel frontend + Render backend wired; deck and post updated with live URLs
Co-Authored-By: Claude Fable 5 <noreply@anthropic.com>
Claude-Session: https://claude.ai/code/session_019A8YQc7WWoitbc7BECpajF
</commit_message>
<xml_diff>
--- a/docs/pitch/Sentinel-Pitch.pptx
+++ b/docs/pitch/Sentinel-Pitch.pptx
@@ -4582,7 +4582,7 @@
                 </a:solidFill>
                 <a:latin typeface="Consolas"/>
               </a:rPr>
-              <a:t>live demo: coming soon (Vercel)</a:t>
+              <a:t>https://sentinel-phi-seven-74.vercel.app</a:t>
             </a:r>
           </a:p>
         </p:txBody>
@@ -10298,7 +10298,7 @@
                 </a:solidFill>
                 <a:latin typeface="Consolas"/>
               </a:rPr>
-              <a:t>web  live demo: coming soon (Vercel)</a:t>
+              <a:t>web  https://sentinel-phi-seven-74.vercel.app</a:t>
             </a:r>
           </a:p>
           <a:p>
@@ -10310,7 +10310,7 @@
                 </a:solidFill>
                 <a:latin typeface="Consolas"/>
               </a:rPr>
-              <a:t>api  API: coming soon (Railway)</a:t>
+              <a:t>api  https://sentinel-api-mf68.onrender.com</a:t>
             </a:r>
           </a:p>
           <a:p>
@@ -13337,7 +13337,7 @@
                 </a:solidFill>
                 <a:latin typeface="Segoe UI"/>
               </a:rPr>
-              <a:t> live demo: coming soon (Vercel)  (admin@sentinel.local / admin12345)</a:t>
+              <a:t> https://sentinel-phi-seven-74.vercel.app  (admin@sentinel.local / admin12345)</a:t>
             </a:r>
           </a:p>
           <a:p>

</xml_diff>